<commit_message>
finalized version of project proposal presentation
</commit_message>
<xml_diff>
--- a/Project-II_Presentation.pptx
+++ b/Project-II_Presentation.pptx
@@ -252,7 +252,7 @@
           <a:p>
             <a:fld id="{E668DC72-0701-4922-B9D1-CBFB540736DA}" type="datetimeFigureOut">
               <a:rPr lang="en-IN" smtClean="0"/>
-              <a:t>03-05-2026</a:t>
+              <a:t>05-05-2026</a:t>
             </a:fld>
             <a:endParaRPr lang="en-IN" dirty="0"/>
           </a:p>
@@ -2472,7 +2472,7 @@
                   </a:prstClr>
                 </a:solidFill>
               </a:rPr>
-              <a:t>5/3/2026</a:t>
+              <a:t>5/5/2026</a:t>
             </a:fld>
             <a:endParaRPr lang="en-US" dirty="0">
               <a:solidFill>
@@ -3340,271 +3340,69 @@
           <a:chExt cx="0" cy="0"/>
         </a:xfrm>
       </p:grpSpPr>
-      <p:sp>
-        <p:nvSpPr>
-          <p:cNvPr id="4" name="Title 1">
+      <p:graphicFrame>
+        <p:nvGraphicFramePr>
+          <p:cNvPr id="2" name="Object 1">
             <a:extLst>
               <a:ext uri="{FF2B5EF4-FFF2-40B4-BE49-F238E27FC236}">
-                <a16:creationId xmlns:a16="http://schemas.microsoft.com/office/drawing/2014/main" id="{55251EF4-A314-482F-B2DB-83B2FD856F35}"/>
+                <a16:creationId xmlns:a16="http://schemas.microsoft.com/office/drawing/2014/main" id="{2ABA637A-BF3E-DFC4-2B12-2B46BAD2FE09}"/>
               </a:ext>
             </a:extLst>
           </p:cNvPr>
-          <p:cNvSpPr>
-            <a:spLocks noGrp="1"/>
-          </p:cNvSpPr>
+          <p:cNvGraphicFramePr>
+            <a:graphicFrameLocks noChangeAspect="1"/>
+          </p:cNvGraphicFramePr>
           <p:nvPr>
-            <p:ph type="title"/>
+            <p:extLst>
+              <p:ext uri="{D42A27DB-BD31-4B8C-83A1-F6EECF244321}">
+                <p14:modId xmlns:p14="http://schemas.microsoft.com/office/powerpoint/2010/main" val="827320969"/>
+              </p:ext>
+            </p:extLst>
           </p:nvPr>
-        </p:nvSpPr>
-        <p:spPr>
-          <a:xfrm>
-            <a:off x="163850" y="126291"/>
-            <a:ext cx="3019853" cy="554587"/>
-          </a:xfrm>
-        </p:spPr>
-        <p:txBody>
-          <a:bodyPr/>
-          <a:lstStyle/>
-          <a:p>
-            <a:r>
-              <a:rPr lang="en-US" dirty="0">
-                <a:solidFill>
-                  <a:srgbClr val="0070C0"/>
-                </a:solidFill>
-              </a:rPr>
-              <a:t>GANTT CHART</a:t>
-            </a:r>
-          </a:p>
-        </p:txBody>
-      </p:sp>
-      <p:pic>
-        <p:nvPicPr>
-          <p:cNvPr id="6" name="Picture 5">
-            <a:extLst>
-              <a:ext uri="{FF2B5EF4-FFF2-40B4-BE49-F238E27FC236}">
-                <a16:creationId xmlns:a16="http://schemas.microsoft.com/office/drawing/2014/main" id="{7BE64C4B-1BE5-4719-A34B-E7148A96D832}"/>
-              </a:ext>
-            </a:extLst>
-          </p:cNvPr>
-          <p:cNvPicPr>
-            <a:picLocks noChangeAspect="1"/>
-          </p:cNvPicPr>
-          <p:nvPr/>
-        </p:nvPicPr>
-        <p:blipFill>
-          <a:blip r:embed="rId2">
-            <a:extLst>
-              <a:ext uri="{28A0092B-C50C-407E-A947-70E740481C1C}">
-                <a14:useLocalDpi xmlns:a14="http://schemas.microsoft.com/office/drawing/2010/main" val="0"/>
-              </a:ext>
-            </a:extLst>
-          </a:blip>
-          <a:stretch>
-            <a:fillRect/>
-          </a:stretch>
-        </p:blipFill>
-        <p:spPr>
-          <a:xfrm>
-            <a:off x="3785490" y="149426"/>
-            <a:ext cx="8155933" cy="6559148"/>
-          </a:xfrm>
-          <a:prstGeom prst="rect">
-            <a:avLst/>
-          </a:prstGeom>
-        </p:spPr>
-      </p:pic>
-      <p:sp>
-        <p:nvSpPr>
-          <p:cNvPr id="7" name="Content Placeholder 2">
-            <a:extLst>
-              <a:ext uri="{FF2B5EF4-FFF2-40B4-BE49-F238E27FC236}">
-                <a16:creationId xmlns:a16="http://schemas.microsoft.com/office/drawing/2014/main" id="{4AC17D07-46B6-4527-AF5C-2C4CF78DA03A}"/>
-              </a:ext>
-            </a:extLst>
-          </p:cNvPr>
-          <p:cNvSpPr txBox="1">
-            <a:spLocks/>
-          </p:cNvSpPr>
-          <p:nvPr/>
-        </p:nvSpPr>
-        <p:spPr>
-          <a:xfrm>
-            <a:off x="250577" y="1231143"/>
-            <a:ext cx="2846400" cy="5223272"/>
-          </a:xfrm>
-          <a:prstGeom prst="rect">
-            <a:avLst/>
-          </a:prstGeom>
-        </p:spPr>
-        <p:txBody>
-          <a:bodyPr/>
-          <a:lstStyle>
-            <a:lvl1pPr marL="342900" indent="-342900" algn="l" rtl="0" eaLnBrk="1" fontAlgn="base" hangingPunct="1">
-              <a:spcBef>
-                <a:spcPct val="20000"/>
-              </a:spcBef>
-              <a:spcAft>
-                <a:spcPct val="0"/>
-              </a:spcAft>
-              <a:buFont typeface="Arial" charset="0"/>
-              <a:buChar char="•"/>
-              <a:defRPr sz="3200" kern="1200">
-                <a:solidFill>
-                  <a:schemeClr val="tx1"/>
-                </a:solidFill>
-                <a:latin typeface="+mn-lt"/>
-                <a:ea typeface="+mn-ea"/>
-                <a:cs typeface="+mn-cs"/>
-              </a:defRPr>
-            </a:lvl1pPr>
-            <a:lvl2pPr marL="742950" indent="-285750" algn="l" rtl="0" eaLnBrk="1" fontAlgn="base" hangingPunct="1">
-              <a:spcBef>
-                <a:spcPct val="20000"/>
-              </a:spcBef>
-              <a:spcAft>
-                <a:spcPct val="0"/>
-              </a:spcAft>
-              <a:buFont typeface="Arial" charset="0"/>
-              <a:buChar char="–"/>
-              <a:defRPr sz="2800" kern="1200">
-                <a:solidFill>
-                  <a:schemeClr val="tx1"/>
-                </a:solidFill>
-                <a:latin typeface="+mn-lt"/>
-                <a:ea typeface="+mn-ea"/>
-                <a:cs typeface="+mn-cs"/>
-              </a:defRPr>
-            </a:lvl2pPr>
-            <a:lvl3pPr marL="1143000" indent="-228600" algn="l" rtl="0" eaLnBrk="1" fontAlgn="base" hangingPunct="1">
-              <a:spcBef>
-                <a:spcPct val="20000"/>
-              </a:spcBef>
-              <a:spcAft>
-                <a:spcPct val="0"/>
-              </a:spcAft>
-              <a:buFont typeface="Arial" charset="0"/>
-              <a:buChar char="•"/>
-              <a:defRPr sz="2400" kern="1200">
-                <a:solidFill>
-                  <a:schemeClr val="tx1"/>
-                </a:solidFill>
-                <a:latin typeface="+mn-lt"/>
-                <a:ea typeface="+mn-ea"/>
-                <a:cs typeface="+mn-cs"/>
-              </a:defRPr>
-            </a:lvl3pPr>
-            <a:lvl4pPr marL="1600200" indent="-228600" algn="l" rtl="0" eaLnBrk="1" fontAlgn="base" hangingPunct="1">
-              <a:spcBef>
-                <a:spcPct val="20000"/>
-              </a:spcBef>
-              <a:spcAft>
-                <a:spcPct val="0"/>
-              </a:spcAft>
-              <a:buFont typeface="Arial" charset="0"/>
-              <a:buChar char="–"/>
-              <a:defRPr sz="2000" kern="1200">
-                <a:solidFill>
-                  <a:schemeClr val="tx1"/>
-                </a:solidFill>
-                <a:latin typeface="+mn-lt"/>
-                <a:ea typeface="+mn-ea"/>
-                <a:cs typeface="+mn-cs"/>
-              </a:defRPr>
-            </a:lvl4pPr>
-            <a:lvl5pPr marL="2057400" indent="-228600" algn="l" rtl="0" eaLnBrk="1" fontAlgn="base" hangingPunct="1">
-              <a:spcBef>
-                <a:spcPct val="20000"/>
-              </a:spcBef>
-              <a:spcAft>
-                <a:spcPct val="0"/>
-              </a:spcAft>
-              <a:buFont typeface="Arial" charset="0"/>
-              <a:buChar char="»"/>
-              <a:defRPr sz="2000" kern="1200">
-                <a:solidFill>
-                  <a:schemeClr val="tx1"/>
-                </a:solidFill>
-                <a:latin typeface="+mn-lt"/>
-                <a:ea typeface="+mn-ea"/>
-                <a:cs typeface="+mn-cs"/>
-              </a:defRPr>
-            </a:lvl5pPr>
-            <a:lvl6pPr marL="2514600" indent="-228600" algn="l" defTabSz="914400" rtl="0" eaLnBrk="1" latinLnBrk="0" hangingPunct="1">
-              <a:spcBef>
-                <a:spcPct val="20000"/>
-              </a:spcBef>
-              <a:buFont typeface="Arial" pitchFamily="34" charset="0"/>
-              <a:buChar char="•"/>
-              <a:defRPr sz="2000" kern="1200">
-                <a:solidFill>
-                  <a:schemeClr val="tx1"/>
-                </a:solidFill>
-                <a:latin typeface="+mn-lt"/>
-                <a:ea typeface="+mn-ea"/>
-                <a:cs typeface="+mn-cs"/>
-              </a:defRPr>
-            </a:lvl6pPr>
-            <a:lvl7pPr marL="2971800" indent="-228600" algn="l" defTabSz="914400" rtl="0" eaLnBrk="1" latinLnBrk="0" hangingPunct="1">
-              <a:spcBef>
-                <a:spcPct val="20000"/>
-              </a:spcBef>
-              <a:buFont typeface="Arial" pitchFamily="34" charset="0"/>
-              <a:buChar char="•"/>
-              <a:defRPr sz="2000" kern="1200">
-                <a:solidFill>
-                  <a:schemeClr val="tx1"/>
-                </a:solidFill>
-                <a:latin typeface="+mn-lt"/>
-                <a:ea typeface="+mn-ea"/>
-                <a:cs typeface="+mn-cs"/>
-              </a:defRPr>
-            </a:lvl7pPr>
-            <a:lvl8pPr marL="3429000" indent="-228600" algn="l" defTabSz="914400" rtl="0" eaLnBrk="1" latinLnBrk="0" hangingPunct="1">
-              <a:spcBef>
-                <a:spcPct val="20000"/>
-              </a:spcBef>
-              <a:buFont typeface="Arial" pitchFamily="34" charset="0"/>
-              <a:buChar char="•"/>
-              <a:defRPr sz="2000" kern="1200">
-                <a:solidFill>
-                  <a:schemeClr val="tx1"/>
-                </a:solidFill>
-                <a:latin typeface="+mn-lt"/>
-                <a:ea typeface="+mn-ea"/>
-                <a:cs typeface="+mn-cs"/>
-              </a:defRPr>
-            </a:lvl8pPr>
-            <a:lvl9pPr marL="3886200" indent="-228600" algn="l" defTabSz="914400" rtl="0" eaLnBrk="1" latinLnBrk="0" hangingPunct="1">
-              <a:spcBef>
-                <a:spcPct val="20000"/>
-              </a:spcBef>
-              <a:buFont typeface="Arial" pitchFamily="34" charset="0"/>
-              <a:buChar char="•"/>
-              <a:defRPr sz="2000" kern="1200">
-                <a:solidFill>
-                  <a:schemeClr val="tx1"/>
-                </a:solidFill>
-                <a:latin typeface="+mn-lt"/>
-                <a:ea typeface="+mn-ea"/>
-                <a:cs typeface="+mn-cs"/>
-              </a:defRPr>
-            </a:lvl9pPr>
-          </a:lstStyle>
-          <a:p>
-            <a:pPr marL="0" indent="0">
-              <a:buNone/>
-            </a:pPr>
-            <a:r>
-              <a:rPr lang="en-US" i="1" dirty="0"/>
-              <a:t>(For 10 Week Projected Gant Chart for Blood Donation Finder)</a:t>
-            </a:r>
-            <a:r>
-              <a:rPr lang="en-US" dirty="0"/>
-              <a:t> </a:t>
-            </a:r>
-          </a:p>
-        </p:txBody>
-      </p:sp>
+        </p:nvGraphicFramePr>
+        <p:xfrm>
+          <a:off x="0" y="0"/>
+          <a:ext cx="12192000" cy="6857999"/>
+        </p:xfrm>
+        <a:graphic>
+          <a:graphicData uri="http://schemas.openxmlformats.org/presentationml/2006/ole">
+            <mc:AlternateContent xmlns:mc="http://schemas.openxmlformats.org/markup-compatibility/2006">
+              <mc:Choice xmlns:v="urn:schemas-microsoft-com:vml" Requires="v">
+                <p:oleObj name="Worksheet" r:id="rId2" imgW="11376837" imgH="7330314" progId="Excel.Sheet.12">
+                  <p:embed/>
+                </p:oleObj>
+              </mc:Choice>
+              <mc:Fallback>
+                <p:oleObj name="Worksheet" r:id="rId2" imgW="11376837" imgH="7330314" progId="Excel.Sheet.12">
+                  <p:embed/>
+                  <p:pic>
+                    <p:nvPicPr>
+                      <p:cNvPr id="0" name=""/>
+                      <p:cNvPicPr/>
+                      <p:nvPr/>
+                    </p:nvPicPr>
+                    <p:blipFill>
+                      <a:blip r:embed="rId3"/>
+                      <a:stretch>
+                        <a:fillRect/>
+                      </a:stretch>
+                    </p:blipFill>
+                    <p:spPr>
+                      <a:xfrm>
+                        <a:off x="0" y="0"/>
+                        <a:ext cx="12192000" cy="6857999"/>
+                      </a:xfrm>
+                      <a:prstGeom prst="rect">
+                        <a:avLst/>
+                      </a:prstGeom>
+                    </p:spPr>
+                  </p:pic>
+                </p:oleObj>
+              </mc:Fallback>
+            </mc:AlternateContent>
+          </a:graphicData>
+        </a:graphic>
+      </p:graphicFrame>
     </p:spTree>
     <p:extLst>
       <p:ext uri="{BB962C8B-B14F-4D97-AF65-F5344CB8AC3E}">
@@ -5296,7 +5094,7 @@
             </a:pPr>
             <a:r>
               <a:rPr lang="en-US" dirty="0"/>
-              <a:t>So, this project aims to develop a fast and reliable blood donation web application to improve emergency blood access and reduce delays in critical situations. It will be developed over a 10-week timeline using compatible technologies. Overall, it provides an efficient and simple solution to improve blood availability and save lives.</a:t>
+              <a:t>So, this project aims to develop a fast and reliable blood donation web application to improve emergency blood access and reduce delays in critical situations. It will be developed over a 13-week timeline using compatible technologies. Overall, it provides an efficient and simple solution to improve blood availability and save lives.</a:t>
             </a:r>
           </a:p>
         </p:txBody>
@@ -6126,13 +5924,25 @@
             <a:endParaRPr lang="en-US" dirty="0"/>
           </a:p>
           <a:p>
-            <a:pPr algn="l"/>
             <a:r>
               <a:rPr lang="en-US" b="0" i="0" dirty="0">
                 <a:effectLst/>
               </a:rPr>
               <a:t>Sankalp India Foundation's app</a:t>
             </a:r>
+            <a:r>
+              <a:rPr lang="en-US" dirty="0"/>
+              <a:t>, https://hamrolifebank.com/</a:t>
+            </a:r>
+            <a:endParaRPr lang="en-US" b="0" i="0" dirty="0">
+              <a:effectLst/>
+            </a:endParaRPr>
+          </a:p>
+          <a:p>
+            <a:pPr algn="l"/>
+            <a:endParaRPr lang="en-US" b="0" i="0" dirty="0">
+              <a:effectLst/>
+            </a:endParaRPr>
           </a:p>
           <a:p>
             <a:pPr algn="l"/>

</xml_diff>